<commit_message>
Redeploy patched contracts to testnet; propagate new addresses everywhere
New 46630 deployment includes the _isHoard guard (factory() wired,
MAX_EPOCH_TOKENS=16 verified on-chain). All 9 contracts re-verified on
Blockscout. Addresses updated in README, GRANT.md, pitch deck, SECURITY.md;
web config auto-synced; Vercel redeployed and loxley-dex.vercel.app
re-aliased (quote verified against new pool reserves: 0.001 ETH -> 0.6029
GOLD, matches on-chain math).

Co-Authored-By: Claude Fable 5 <noreply@anthropic.com>
</commit_message>
<xml_diff>
--- a/docs/loxley-pitch-deck.pptx
+++ b/docs/loxley-pitch-deck.pptx
@@ -3440,7 +3440,7 @@
                 <a:ea typeface="Courier New" pitchFamily="34" charset="-122"/>
                 <a:cs typeface="Courier New" pitchFamily="34" charset="-120"/>
               </a:rPr>
-              <a:t>0xc1B3d94b980F83De0909cf7BB7da833aCfC56720</a:t>
+              <a:t>0xD76e7a2A8B3c06D62b3F57622a15b9F27945CEA2</a:t>
             </a:r>
             <a:endParaRPr lang="en-US" sz="950" dirty="0"/>
           </a:p>
@@ -3518,7 +3518,7 @@
                 <a:ea typeface="Courier New" pitchFamily="34" charset="-122"/>
                 <a:cs typeface="Courier New" pitchFamily="34" charset="-120"/>
               </a:rPr>
-              <a:t>0xbA2717Be7ad661B5582d9050735d85Dec043225F</a:t>
+              <a:t>0x9CbDE27ACEdd5DDd4BC7A152247BeB929C1144F7</a:t>
             </a:r>
             <a:endParaRPr lang="en-US" sz="950" dirty="0"/>
           </a:p>
@@ -3596,7 +3596,7 @@
                 <a:ea typeface="Courier New" pitchFamily="34" charset="-122"/>
                 <a:cs typeface="Courier New" pitchFamily="34" charset="-120"/>
               </a:rPr>
-              <a:t>0xEC81858FaB25e9C5C081777B9243E68E5Bc7f6F5</a:t>
+              <a:t>0xf1553459b978Aa8c9B85b0769dB3b3D8D2AD1356</a:t>
             </a:r>
             <a:endParaRPr lang="en-US" sz="950" dirty="0"/>
           </a:p>
@@ -3674,7 +3674,7 @@
                 <a:ea typeface="Courier New" pitchFamily="34" charset="-122"/>
                 <a:cs typeface="Courier New" pitchFamily="34" charset="-120"/>
               </a:rPr>
-              <a:t>0x6662Fb018E2f92ccA89B30C5c223004455b746CE</a:t>
+              <a:t>0x5355Ca93a24821bc77ee6d19DAF29219328afBc6</a:t>
             </a:r>
             <a:endParaRPr lang="en-US" sz="950" dirty="0"/>
           </a:p>
@@ -3752,7 +3752,7 @@
                 <a:ea typeface="Courier New" pitchFamily="34" charset="-122"/>
                 <a:cs typeface="Courier New" pitchFamily="34" charset="-120"/>
               </a:rPr>
-              <a:t>0x06F140568bE0f5eb7B562dd3ebBf037F6B95E9f5</a:t>
+              <a:t>0xb274cf9770D87cb5c1D3DcAc0495D14814EbB809</a:t>
             </a:r>
             <a:endParaRPr lang="en-US" sz="950" dirty="0"/>
           </a:p>

</xml_diff>

<commit_message>
SpoilsSplitter: disclosed 50/50 protocol-fee split (Share / guild treasury)
New immutable splitter sits as factory.feeTo: half the 0.05% protocol fee
to MerryMenShare, half to the guild treasury. Ratio fixed at deploy;
treasury rotatable only by itself; split() permissionless to two hardcoded
destinations. 6 new tests incl. end-to-end through a real pair (59/59).
Live on testnet at 0xf5D72f9639F3ccd5A517D02fab663739E846B708 (verified,
factory repointed in place — no redeploy). Disclosure everywhere: UI copy
(hero, swap fee row, Share page + flow caption), README, SECURITY, GRANT,
pitch deck. demo.sh runs the split; Deploy.s.sol takes TREASURY/MERRY_BPS.

Co-Authored-By: Claude Fable 5 <noreply@anthropic.com>
</commit_message>
<xml_diff>
--- a/docs/loxley-pitch-deck.pptx
+++ b/docs/loxley-pitch-deck.pptx
@@ -2690,7 +2690,7 @@
                 <a:ea typeface="Calibri" pitchFamily="34" charset="-122"/>
                 <a:cs typeface="Calibri" pitchFamily="34" charset="-120"/>
               </a:rPr>
-              <a:t>0.05% of all volume</a:t>
+              <a:t>0.05% → ½ Share · ½ guild</a:t>
             </a:r>
             <a:endParaRPr lang="en-US" sz="1150" dirty="0"/>
           </a:p>
@@ -3179,7 +3179,7 @@
                 <a:ea typeface="Calibri" pitchFamily="34" charset="-122"/>
                 <a:cs typeface="Calibri" pitchFamily="34" charset="-120"/>
               </a:rPr>
-              <a:t>spam-damped, fully on-chain</a:t>
+              <a:t>spam-damped · split fixed at deploy</a:t>
             </a:r>
             <a:endParaRPr lang="en-US" sz="1000" dirty="0"/>
           </a:p>

</xml_diff>